<commit_message>
Add speaking script and sync it into the deck's speaker notes
SCRIPT.md carries the full word-for-word script for the 9-slide deck, with a
per-slide time budget totalling about four minutes, demo cues and a fallback
line if the live site fails, delivery notes, and prepared answers for the
questions a panel is most likely to ask.

The same wording now lives in each slide's speaker notes, so Presenter View
shows exactly what is being rehearsed rather than a paraphrase.

Co-Authored-By: Claude Opus 5 <noreply@anthropic.com>
Claude-Session: https://claude.ai/code/session_01Xt1LAvHi4hjWx1pndDMtZk
</commit_message>
<xml_diff>
--- a/presentation/Elysian-Internship-Presentation.pptx
+++ b/presentation/Elysian-Internship-Presentation.pptx
@@ -510,7 +510,7 @@
           <a:p>
             <a:r>
               <a:rPr lang="en-US" dirty="0"/>
-              <a:t>(~10s) Good morning. I'm Rayyan Pasha, Year 3, Digital Transformation at Atria. I intern as Founder's Desk Associate at TIPS Founder's Desk, and today I'm presenting Elysian Celebrations — the platform I've been building there.</a:t>
+              <a:t>[~13s]  Good morning. I'm Rayyan Pasha, third year, Digital Transformation at Atria. I intern at TIPS Founder's Desk, and today I'm showing you what I built there — Elysian Celebrations.</a:t>
             </a:r>
             <a:endParaRPr lang="en-US" dirty="0"/>
           </a:p>
@@ -598,7 +598,7 @@
           <a:p>
             <a:r>
               <a:rPr lang="en-US" dirty="0"/>
-              <a:t>(~30s) My role spans six areas — strategy support, digitising operations, venture building, EdTech and chatbot prototypes, hospitality and events, and research. Across those I've delivered SOPs, dashboards, trackers, chatbot prototypes and business decks. Area C — Elysian — is where most of my build work went, so that's what I'll focus on today.</a:t>
+              <a:t>[~29s]  My role is Founder's Desk Associate, reporting to Padmini Raghavendra, the Director. The mandate covers six areas — strategy support, digitising operations, venture building, EdTech and chatbot prototypes, hospitality and events, and research. Across those I've delivered SOPs, dashboards, trackers, chatbot prototypes and business decks. But area C — Elysian — is where most of my build work went. So that's what I'll focus on today.</a:t>
             </a:r>
             <a:endParaRPr lang="en-US" dirty="0"/>
           </a:p>
@@ -686,7 +686,7 @@
           <a:p>
             <a:r>
               <a:rPr lang="en-US" dirty="0"/>
-              <a:t>(~25s) A multi-day Indian celebration means twenty-plus functions across five days. Today that's run across six disconnected tools, with the client acting as the integration layer. Three problems: nothing is connected, everything is free text, and nobody can see readiness.</a:t>
+              <a:t>[~24s]  Here's the problem. Planning a five-day celebration means twenty-plus functions. Right now that runs on spreadsheets, WhatsApp and memory. Nothing is connected — change the guest count and the menu quietly goes stale. Everything is typed by hand, so no system can price it or book it. And nobody can answer a simple question: are we ready for Day Three?</a:t>
             </a:r>
             <a:endParaRPr lang="en-US" dirty="0"/>
           </a:p>
@@ -774,7 +774,7 @@
           <a:p>
             <a:r>
               <a:rPr lang="en-US" dirty="0"/>
-              <a:t>(~35s) Elysian answers that in three layers. Define shapes the event. Map is the core — a visual flow map where you drill from the event down to one step of one function, so the editor that opens is small enough to finish. Finalize proves readiness. It's 61,000 lines of TypeScript, 62 routes, 59 API endpoints, 27 tables, and four role-based portals over one shared spine.</a:t>
+              <a:t>[~33s]  Elysian answers that in three layers. DEFINE shapes the event — type, days, time blocks. MAP is the core. It's a visual flow map where you drill from the event down to one day, one function, one step — so the form that finally opens is small enough to actually finish. FINALIZE proves readiness. It's sixty-one thousand lines of TypeScript, sixty-two routes, fifty-nine API endpoints, twenty-seven database tables, and four separate portals — client, vendor, manager and admin.</a:t>
             </a:r>
             <a:endParaRPr lang="en-US" dirty="0"/>
           </a:p>
@@ -862,7 +862,13 @@
           <a:p>
             <a:r>
               <a:rPr lang="en-US" dirty="0"/>
-              <a:t>(~50s) DEMO — keep to three beats and do not wander. 1) The flow map: drill hub → day → function → step. 2) Open a need and select a vendor catalogue row. 3) Show the readiness gate holding the client price back. Then close the tab and return to this deck. If the site or wifi fails, say so once and move on — the next slide covers the stack anyway.</a:t>
+              <a:t>[~50s]  DEMO — site already open, already logged in, tab on the flow map.  
+SAY: Let me show you the real thing.  
+(1) FLOW MAP — This is the flow map. I start at the event, open a day, then a function — and notice the editor only opens once I pick a step.  
+(2) CATALOGUE — Vendors are selected from a real catalogue, inside the need they belong to. Never typed. That's what makes them priceable and bookable.  
+(3) READINESS — And this is the readiness gate: the client's final price only appears once the function is genuinely complete.  
+SAY: Let me come back to the deck.  
+IF IT FAILS: say 'Looks like the connection's not cooperating — let me carry on', once, and move on. Do not debug.</a:t>
             </a:r>
             <a:endParaRPr lang="en-US" dirty="0"/>
           </a:p>
@@ -950,7 +956,7 @@
           <a:p>
             <a:r>
               <a:rPr lang="en-US" dirty="0"/>
-              <a:t>(~25s) The stack is deliberately production-grade. Next.js 16 and React 19 on the front. Supabase Postgres behind it, with 27 tables and 25 reviewed migrations — every schema change in version control, none typed into a dashboard. Clerk for auth, with row-level security on and ownership re-checked server-side. Shipped continuously through Vercel.</a:t>
+              <a:t>[~21s]  The stack is deliberately production-grade. Next.js sixteen and React nineteen on the front end. Supabase Postgres behind it, with twenty-seven tables and twenty-five migrations — every schema change is in version control, none of it typed into a dashboard. Clerk handles authentication. And it ships continuously through Vercel.</a:t>
             </a:r>
             <a:endParaRPr lang="en-US" dirty="0"/>
           </a:p>
@@ -1038,7 +1044,8 @@
           <a:p>
             <a:r>
               <a:rPr lang="en-US" dirty="0"/>
-              <a:t>(~35s) Skills first: I went from writing features to owning a system — data modelling, authorisation design, security auditing, and directing AI tools without losing the architecture. The hardest challenge was readiness being computed twice with different rules, where one copy decided whether a client could see a price. I collapsed it to one server-side contract. The lesson: duplicated logic near money is a security bug, not untidiness.</a:t>
+              <a:t>[~35s]  What I gained: I went from writing features to owning a system — data modelling, authorisation design, and auditing my own code.  
+The hardest challenge was this. Readiness was being calculated twice — once in the browser, once on the server — with different rules. And one of those copies decided whether a client could see a price. I collapsed it into a single server-side contract. The lesson stuck with me: duplicated logic near money isn't untidy — it's a security bug.</a:t>
             </a:r>
             <a:endParaRPr lang="en-US" dirty="0"/>
           </a:p>
@@ -1126,7 +1133,8 @@
           <a:p>
             <a:r>
               <a:rPr lang="en-US" dirty="0"/>
-              <a:t>(~35s) My programme is Digital Transformation, and this internship was that, literally. Process mapping became the flow map. Data modelling became 27 tables with rules enforced in SQL. Data-driven decision making became readiness scoring. Looking forward — I'm still with TIPS through December 2026. The next wave is architecture rather than features: transaction boundaries, splitting the money ledger, and extending Elysian beyond events into hospitality, education and real estate.</a:t>
+              <a:t>[~29s]  My programme is Digital Transformation, and this internship was exactly that. Process mapping became the flow map. Database modelling became twenty-seven tables with the business rules enforced in SQL. Data-driven decision making became readiness scoring instead of guesswork.  
+And I'm not finished. I'm with TIPS through December twenty twenty-six. Next is architecture rather than features — and extending Elysian beyond events into hospitality, education and real estate.</a:t>
             </a:r>
             <a:endParaRPr lang="en-US" dirty="0"/>
           </a:p>
@@ -1214,7 +1222,7 @@
           <a:p>
             <a:r>
               <a:rPr lang="en-US" dirty="0"/>
-              <a:t>(~10s) Thank you — happy to take questions.</a:t>
+              <a:t>[~9s]  That's Elysian — built over the last year, and still being built. Thank you. I'm happy to take questions.</a:t>
             </a:r>
             <a:endParaRPr lang="en-US" dirty="0"/>
           </a:p>

</xml_diff>